<commit_message>
docs: update manuals + decks to v1.2 (PMBOK 6 = 4th framework)
Brings the Architecture, User and Operation manuals (and summary decks) current
with PMBOK 6th ed as the fourth live framework behind apps.p3mai.com/pmbok.

- DOC-01: four-framework framing; new §6.4 on the container-vs-hub swimlane grid
  (config.lifecycle_layer="hub") that renders PMBOK's 5×10 process matrix;
  provenance row (build_pmbok.py, 187/400) + pmbok-method-map service; roadmap.
- DOC-02: four-methods framing; /pmbok address; new §12.3 on the PMBOK map (KA×PG
  grid, Inputs&Outputs/Tools layers, I/O/T codes, curated-indicative ITTO note).
- DOC-03: pmbok-method-map service + /pmbok route + build_pmbok in the seed/
  builder steps; four-service summary.
- docstyle "Applies to", README + doc-control rows bumped to v1.2. Regenerated
  all 3 .docx + 3 .pptx.

Co-Authored-By: Claude Opus 4.8 <noreply@anthropic.com>
</commit_message>
<xml_diff>
--- a/docs/01_Architecture_and_Design_Summary.pptx
+++ b/docs/01_Architecture_and_Design_Summary.pptx
@@ -3494,7 +3494,7 @@
                 </a:solidFill>
                 <a:latin typeface="Segoe UI"/>
               </a:rPr>
-              <a:t>•  Done — MSP 5th Edition and SAFe 6.0 Essential are live behind the front door.</a:t>
+              <a:t>•  Done — MSP, SAFe 6.0 Essential and PMBOK 6th ed are live behind the front door.</a:t>
             </a:r>
           </a:p>
           <a:p>
@@ -3513,7 +3513,7 @@
                 </a:solidFill>
                 <a:latin typeface="Segoe UI"/>
               </a:rPr>
-              <a:t>•  SME-verify the MSP / SAFe indicative activity breakdowns and marks.</a:t>
+              <a:t>•  SME-verify the indicative activity breakdowns / PMBOK ITTO cross-references.</a:t>
             </a:r>
           </a:p>
           <a:p>
@@ -3532,7 +3532,7 @@
                 </a:solidFill>
                 <a:latin typeface="Segoe UI"/>
               </a:rPr>
-              <a:t>•  Extend SAFe beyond Essential (Portfolio / Large Solution).</a:t>
+              <a:t>•  Extend SAFe beyond Essential; consider PMBOK 7/8 (principles + performance domains).</a:t>
             </a:r>
           </a:p>
           <a:p>
@@ -3823,7 +3823,7 @@
                 </a:solidFill>
                 <a:latin typeface="Segoe UI"/>
               </a:rPr>
-              <a:t>•  Three methods as interactive network graphs: PRINCE2 7, MSP 5th ed, SAFe 6.0 Essential.</a:t>
+              <a:t>•  Four methods as interactive network graphs: PRINCE2 7, MSP 5th ed, SAFe 6.0 Essential, PMBOK 6th ed.</a:t>
             </a:r>
           </a:p>
           <a:p>
@@ -3842,7 +3842,7 @@
                 </a:solidFill>
                 <a:latin typeface="Segoe UI"/>
               </a:rPr>
-              <a:t>•  Each cross-references its activities to the roles, artefacts, practices and principles around them.</a:t>
+              <a:t>•  Each cross-references its activities/processes to the roles, artefacts, tools and principles around them.</a:t>
             </a:r>
           </a:p>
           <a:p>
@@ -3861,7 +3861,7 @@
                 </a:solidFill>
                 <a:latin typeface="Segoe UI"/>
               </a:rPr>
-              <a:t>•  Single-origin web app; config-driven, framework-agnostic model — a new method is just data.</a:t>
+              <a:t>•  Single-origin web app; config-driven, framework-agnostic model — a new method is (almost) just data.</a:t>
             </a:r>
           </a:p>
         </p:txBody>

</xml_diff>